<commit_message>
Update README with live URL, setup notes, and PPTX revision
- Add deployed Streamlit app link
- Document Python 3.12 requirement and project-root run constraint
- Note missing torch dependency (needed by stable-baselines3)
- Add pre-trained checkpoint clarification and make_deck.js instructions
- Update SmartGrid_RDMU_Topic5.pptx

Co-Authored-By: Claude Sonnet 4.6 <noreply@anthropic.com>
</commit_message>
<xml_diff>
--- a/SmartGrid_RDMU_Topic5.pptx
+++ b/SmartGrid_RDMU_Topic5.pptx
@@ -4,6 +4,9 @@
   <p:sldMasterIdLst>
     <p:sldMasterId id="2147483648" r:id="rId1"/>
   </p:sldMasterIdLst>
+  <p:notesMasterIdLst>
+    <p:notesMasterId r:id="rId13"/>
+  </p:notesMasterIdLst>
   <p:sldIdLst>
     <p:sldId id="256" r:id="rId2"/>
     <p:sldId id="257" r:id="rId3"/>
@@ -15,10 +18,8 @@
     <p:sldId id="263" r:id="rId9"/>
     <p:sldId id="264" r:id="rId10"/>
     <p:sldId id="265" r:id="rId11"/>
+    <p:sldId id="266" r:id="rId12"/>
   </p:sldIdLst>
-  <p:notesMasterIdLst>
-    <p:notesMasterId r:id="rId12"/>
-  </p:notesMasterIdLst>
   <p:sldSz cx="12192000" cy="6858000"/>
   <p:notesSz cx="6858000" cy="12192000"/>
   <p:defaultTextStyle>
@@ -113,6 +114,11 @@
       </a:defRPr>
     </a:lvl9pPr>
   </p:defaultTextStyle>
+  <p:extLst>
+    <p:ext uri="{EFAFB233-063F-42B5-8137-9DF3F51BA10A}">
+      <p15:sldGuideLst xmlns:p15="http://schemas.microsoft.com/office/powerpoint/2012/main"/>
+    </p:ext>
+  </p:extLst>
 </p:presentation>
 </file>
 
@@ -138,234 +144,10 @@
           <a:chExt cx="0" cy="0"/>
         </a:xfrm>
       </p:grpSpPr>
-      <p:sp>
-        <p:nvSpPr>
-          <p:cNvPr id="2" name="Header Placeholder 1"/>
-          <p:cNvSpPr>
-            <a:spLocks noGrp="1"/>
-          </p:cNvSpPr>
-          <p:nvPr>
-            <p:ph type="hdr" sz="quarter"/>
-          </p:nvPr>
-        </p:nvSpPr>
-        <p:spPr>
-          <a:xfrm>
-            <a:off x="0" y="0"/>
-            <a:ext cx="2971800" cy="458788"/>
-          </a:xfrm>
-          <a:prstGeom prst="rect">
-            <a:avLst/>
-          </a:prstGeom>
-        </p:spPr>
-        <p:txBody>
-          <a:bodyPr vert="horz" lIns="91440" tIns="45720" rIns="91440" bIns="45720" rtlCol="0"/>
-          <a:lstStyle>
-            <a:lvl1pPr algn="l">
-              <a:defRPr sz="1200"/>
-            </a:lvl1pPr>
-          </a:lstStyle>
-          <a:p>
-            <a:endParaRPr lang="en-US"/>
-          </a:p>
-        </p:txBody>
-      </p:sp>
-      <p:sp>
-        <p:nvSpPr>
-          <p:cNvPr id="3" name="Date Placeholder 2"/>
-          <p:cNvSpPr>
-            <a:spLocks noGrp="1"/>
-          </p:cNvSpPr>
-          <p:nvPr>
-            <p:ph type="dt" idx="1"/>
-          </p:nvPr>
-        </p:nvSpPr>
-        <p:spPr>
-          <a:xfrm>
-            <a:off x="3884613" y="0"/>
-            <a:ext cx="2971800" cy="458788"/>
-          </a:xfrm>
-          <a:prstGeom prst="rect">
-            <a:avLst/>
-          </a:prstGeom>
-        </p:spPr>
-        <p:txBody>
-          <a:bodyPr vert="horz" lIns="91440" tIns="45720" rIns="91440" bIns="45720" rtlCol="0"/>
-          <a:lstStyle>
-            <a:lvl1pPr algn="r">
-              <a:defRPr sz="1200"/>
-            </a:lvl1pPr>
-          </a:lstStyle>
-          <a:p>
-            <a:fld id="{5282F153-3F37-0F45-9E97-73ACFA13230C}" type="datetimeFigureOut">
-              <a:rPr lang="en-US"/>
-              <a:t>7/23/19</a:t>
-            </a:fld>
-            <a:endParaRPr lang="en-US"/>
-          </a:p>
-        </p:txBody>
-      </p:sp>
-      <p:sp>
-        <p:nvSpPr>
-          <p:cNvPr id="4" name="Slide Image Placeholder 3"/>
-          <p:cNvSpPr>
-            <a:spLocks noGrp="1" noRot="1" noChangeAspect="1"/>
-          </p:cNvSpPr>
-          <p:nvPr>
-            <p:ph type="sldImg" idx="2"/>
-          </p:nvPr>
-        </p:nvSpPr>
-        <p:spPr>
-          <a:xfrm>
-            <a:off x="685800" y="1143000"/>
-            <a:ext cx="5486400" cy="3086100"/>
-          </a:xfrm>
-          <a:prstGeom prst="rect">
-            <a:avLst/>
-          </a:prstGeom>
-          <a:noFill/>
-          <a:ln w="12700">
-            <a:solidFill>
-              <a:prstClr val="black"/>
-            </a:solidFill>
-          </a:ln>
-        </p:spPr>
-        <p:txBody>
-          <a:bodyPr vert="horz" lIns="91440" tIns="45720" rIns="91440" bIns="45720" rtlCol="0" anchor="ctr"/>
-          <a:lstStyle/>
-          <a:p>
-            <a:endParaRPr lang="en-US"/>
-          </a:p>
-        </p:txBody>
-      </p:sp>
-      <p:sp>
-        <p:nvSpPr>
-          <p:cNvPr id="5" name="Notes Placeholder 4"/>
-          <p:cNvSpPr>
-            <a:spLocks noGrp="1"/>
-          </p:cNvSpPr>
-          <p:nvPr>
-            <p:ph type="body" sz="quarter" idx="3"/>
-          </p:nvPr>
-        </p:nvSpPr>
-        <p:spPr>
-          <a:xfrm>
-            <a:off x="685800" y="4400550"/>
-            <a:ext cx="5486400" cy="3600450"/>
-          </a:xfrm>
-          <a:prstGeom prst="rect">
-            <a:avLst/>
-          </a:prstGeom>
-        </p:spPr>
-        <p:txBody>
-          <a:bodyPr vert="horz" lIns="91440" tIns="45720" rIns="91440" bIns="45720" rtlCol="0"/>
-          <a:lstStyle/>
-          <a:p>
-            <a:pPr lvl="0"/>
-            <a:r>
-              <a:rPr lang="en-US"/>
-              <a:t>Click to edit Master text styles</a:t>
-            </a:r>
-          </a:p>
-          <a:p>
-            <a:pPr lvl="1"/>
-            <a:r>
-              <a:rPr lang="en-US"/>
-              <a:t>Second level</a:t>
-            </a:r>
-          </a:p>
-          <a:p>
-            <a:pPr lvl="2"/>
-            <a:r>
-              <a:rPr lang="en-US"/>
-              <a:t>Third level</a:t>
-            </a:r>
-          </a:p>
-          <a:p>
-            <a:pPr lvl="3"/>
-            <a:r>
-              <a:rPr lang="en-US"/>
-              <a:t>Fourth level</a:t>
-            </a:r>
-          </a:p>
-          <a:p>
-            <a:pPr lvl="4"/>
-            <a:r>
-              <a:rPr lang="en-US"/>
-              <a:t>Fifth level</a:t>
-            </a:r>
-          </a:p>
-        </p:txBody>
-      </p:sp>
-      <p:sp>
-        <p:nvSpPr>
-          <p:cNvPr id="6" name="Footer Placeholder 5"/>
-          <p:cNvSpPr>
-            <a:spLocks noGrp="1"/>
-          </p:cNvSpPr>
-          <p:nvPr>
-            <p:ph type="ftr" sz="quarter" idx="4"/>
-          </p:nvPr>
-        </p:nvSpPr>
-        <p:spPr>
-          <a:xfrm>
-            <a:off x="0" y="8685213"/>
-            <a:ext cx="2971800" cy="458787"/>
-          </a:xfrm>
-          <a:prstGeom prst="rect">
-            <a:avLst/>
-          </a:prstGeom>
-        </p:spPr>
-        <p:txBody>
-          <a:bodyPr vert="horz" lIns="91440" tIns="45720" rIns="91440" bIns="45720" rtlCol="0" anchor="b"/>
-          <a:lstStyle>
-            <a:lvl1pPr algn="l">
-              <a:defRPr sz="1200"/>
-            </a:lvl1pPr>
-          </a:lstStyle>
-          <a:p>
-            <a:endParaRPr lang="en-US"/>
-          </a:p>
-        </p:txBody>
-      </p:sp>
-      <p:sp>
-        <p:nvSpPr>
-          <p:cNvPr id="7" name="Slide Number Placeholder 6"/>
-          <p:cNvSpPr>
-            <a:spLocks noGrp="1"/>
-          </p:cNvSpPr>
-          <p:nvPr>
-            <p:ph type="sldNum" sz="quarter" idx="5"/>
-          </p:nvPr>
-        </p:nvSpPr>
-        <p:spPr>
-          <a:xfrm>
-            <a:off x="3884613" y="8685213"/>
-            <a:ext cx="2971800" cy="458787"/>
-          </a:xfrm>
-          <a:prstGeom prst="rect">
-            <a:avLst/>
-          </a:prstGeom>
-        </p:spPr>
-        <p:txBody>
-          <a:bodyPr vert="horz" lIns="91440" tIns="45720" rIns="91440" bIns="45720" rtlCol="0" anchor="b"/>
-          <a:lstStyle>
-            <a:lvl1pPr algn="r">
-              <a:defRPr sz="1200"/>
-            </a:lvl1pPr>
-          </a:lstStyle>
-          <a:p>
-            <a:fld id="{CE5E9CC1-C706-0F49-92D6-E571CC5EEA8F}" type="slidenum">
-              <a:rPr lang="en-US"/>
-              <a:t>‹#›</a:t>
-            </a:fld>
-            <a:endParaRPr lang="en-US"/>
-          </a:p>
-        </p:txBody>
-      </p:sp>
     </p:spTree>
     <p:extLst>
       <p:ext uri="{BB962C8B-B14F-4D97-AF65-F5344CB8AC3E}">
-        <p14:creationId xmlns:p14="http://schemas.microsoft.com/office/powerpoint/2010/main" val="1024086991"/>
+        <p14:creationId xmlns:p14="http://schemas.microsoft.com/office/powerpoint/2010/main" val="3903459521"/>
       </p:ext>
     </p:extLst>
   </p:cSld>
@@ -509,10 +291,6 @@
           <a:bodyPr/>
           <a:lstStyle/>
           <a:p>
-            <a:r>
-              <a:rPr lang="en-US" dirty="0"/>
-              <a:t/>
-            </a:r>
             <a:endParaRPr lang="en-US" dirty="0"/>
           </a:p>
         </p:txBody>
@@ -597,10 +375,6 @@
           <a:bodyPr/>
           <a:lstStyle/>
           <a:p>
-            <a:r>
-              <a:rPr lang="en-US" dirty="0"/>
-              <a:t/>
-            </a:r>
             <a:endParaRPr lang="en-US" dirty="0"/>
           </a:p>
         </p:txBody>
@@ -632,6 +406,114 @@
     <p:extLst>
       <p:ext uri="{BB962C8B-B14F-4D97-AF65-F5344CB8AC3E}">
         <p14:creationId xmlns:p14="http://schemas.microsoft.com/office/powerpoint/2010/main" val="1024086991"/>
+      </p:ext>
+    </p:extLst>
+  </p:cSld>
+  <p:clrMapOvr>
+    <a:masterClrMapping/>
+  </p:clrMapOvr>
+</p:notes>
+</file>
+
+<file path=ppt/notesSlides/notesSlide11.xml><?xml version="1.0" encoding="utf-8"?>
+<p:notes xmlns:a="http://schemas.openxmlformats.org/drawingml/2006/main" xmlns:r="http://schemas.openxmlformats.org/officeDocument/2006/relationships" xmlns:p="http://schemas.openxmlformats.org/presentationml/2006/main">
+  <p:cSld>
+    <p:spTree>
+      <p:nvGrpSpPr>
+        <p:cNvPr id="1" name="">
+          <a:extLst>
+            <a:ext uri="{FF2B5EF4-FFF2-40B4-BE49-F238E27FC236}">
+              <a16:creationId xmlns:a16="http://schemas.microsoft.com/office/drawing/2014/main" id="{31B09A5D-B3FB-7683-3617-3E4EC3BD6999}"/>
+            </a:ext>
+          </a:extLst>
+        </p:cNvPr>
+        <p:cNvGrpSpPr/>
+        <p:nvPr/>
+      </p:nvGrpSpPr>
+      <p:grpSpPr>
+        <a:xfrm>
+          <a:off x="0" y="0"/>
+          <a:ext cx="0" cy="0"/>
+          <a:chOff x="0" y="0"/>
+          <a:chExt cx="0" cy="0"/>
+        </a:xfrm>
+      </p:grpSpPr>
+      <p:sp>
+        <p:nvSpPr>
+          <p:cNvPr id="2" name="Slide Image Placeholder 1">
+            <a:extLst>
+              <a:ext uri="{FF2B5EF4-FFF2-40B4-BE49-F238E27FC236}">
+                <a16:creationId xmlns:a16="http://schemas.microsoft.com/office/drawing/2014/main" id="{25A152BC-29FF-47A3-2117-40803451CE0D}"/>
+              </a:ext>
+            </a:extLst>
+          </p:cNvPr>
+          <p:cNvSpPr>
+            <a:spLocks noGrp="1" noRot="1" noChangeAspect="1"/>
+          </p:cNvSpPr>
+          <p:nvPr>
+            <p:ph type="sldImg"/>
+          </p:nvPr>
+        </p:nvSpPr>
+        <p:spPr/>
+      </p:sp>
+      <p:sp>
+        <p:nvSpPr>
+          <p:cNvPr id="3" name="Notes Placeholder 2">
+            <a:extLst>
+              <a:ext uri="{FF2B5EF4-FFF2-40B4-BE49-F238E27FC236}">
+                <a16:creationId xmlns:a16="http://schemas.microsoft.com/office/drawing/2014/main" id="{1B606910-250F-564B-B0D3-6421110A3F15}"/>
+              </a:ext>
+            </a:extLst>
+          </p:cNvPr>
+          <p:cNvSpPr>
+            <a:spLocks noGrp="1"/>
+          </p:cNvSpPr>
+          <p:nvPr>
+            <p:ph type="body" idx="1"/>
+          </p:nvPr>
+        </p:nvSpPr>
+        <p:spPr/>
+        <p:txBody>
+          <a:bodyPr/>
+          <a:lstStyle/>
+          <a:p>
+            <a:endParaRPr lang="en-US" dirty="0"/>
+          </a:p>
+        </p:txBody>
+      </p:sp>
+      <p:sp>
+        <p:nvSpPr>
+          <p:cNvPr id="4" name="Slide Number Placeholder 3">
+            <a:extLst>
+              <a:ext uri="{FF2B5EF4-FFF2-40B4-BE49-F238E27FC236}">
+                <a16:creationId xmlns:a16="http://schemas.microsoft.com/office/drawing/2014/main" id="{500B8165-8AC7-720F-1C1A-304ED8285421}"/>
+              </a:ext>
+            </a:extLst>
+          </p:cNvPr>
+          <p:cNvSpPr>
+            <a:spLocks noGrp="1"/>
+          </p:cNvSpPr>
+          <p:nvPr>
+            <p:ph type="sldNum" sz="quarter" idx="10"/>
+          </p:nvPr>
+        </p:nvSpPr>
+        <p:spPr/>
+        <p:txBody>
+          <a:bodyPr/>
+          <a:lstStyle/>
+          <a:p>
+            <a:fld id="{F7021451-1387-4CA6-816F-3879F97B5CBC}" type="slidenum">
+              <a:rPr lang="en-US"/>
+              <a:t>11</a:t>
+            </a:fld>
+            <a:endParaRPr lang="en-US"/>
+          </a:p>
+        </p:txBody>
+      </p:sp>
+    </p:spTree>
+    <p:extLst>
+      <p:ext uri="{BB962C8B-B14F-4D97-AF65-F5344CB8AC3E}">
+        <p14:creationId xmlns:p14="http://schemas.microsoft.com/office/powerpoint/2010/main" val="59474216"/>
       </p:ext>
     </p:extLst>
   </p:cSld>
@@ -685,10 +567,6 @@
           <a:bodyPr/>
           <a:lstStyle/>
           <a:p>
-            <a:r>
-              <a:rPr lang="en-US" dirty="0"/>
-              <a:t/>
-            </a:r>
             <a:endParaRPr lang="en-US" dirty="0"/>
           </a:p>
         </p:txBody>
@@ -773,10 +651,6 @@
           <a:bodyPr/>
           <a:lstStyle/>
           <a:p>
-            <a:r>
-              <a:rPr lang="en-US" dirty="0"/>
-              <a:t/>
-            </a:r>
             <a:endParaRPr lang="en-US" dirty="0"/>
           </a:p>
         </p:txBody>
@@ -861,10 +735,6 @@
           <a:bodyPr/>
           <a:lstStyle/>
           <a:p>
-            <a:r>
-              <a:rPr lang="en-US" dirty="0"/>
-              <a:t/>
-            </a:r>
             <a:endParaRPr lang="en-US" dirty="0"/>
           </a:p>
         </p:txBody>
@@ -949,10 +819,6 @@
           <a:bodyPr/>
           <a:lstStyle/>
           <a:p>
-            <a:r>
-              <a:rPr lang="en-US" dirty="0"/>
-              <a:t/>
-            </a:r>
             <a:endParaRPr lang="en-US" dirty="0"/>
           </a:p>
         </p:txBody>
@@ -1037,10 +903,6 @@
           <a:bodyPr/>
           <a:lstStyle/>
           <a:p>
-            <a:r>
-              <a:rPr lang="en-US" dirty="0"/>
-              <a:t/>
-            </a:r>
             <a:endParaRPr lang="en-US" dirty="0"/>
           </a:p>
         </p:txBody>
@@ -1125,10 +987,6 @@
           <a:bodyPr/>
           <a:lstStyle/>
           <a:p>
-            <a:r>
-              <a:rPr lang="en-US" dirty="0"/>
-              <a:t/>
-            </a:r>
             <a:endParaRPr lang="en-US" dirty="0"/>
           </a:p>
         </p:txBody>
@@ -1213,10 +1071,6 @@
           <a:bodyPr/>
           <a:lstStyle/>
           <a:p>
-            <a:r>
-              <a:rPr lang="en-US" dirty="0"/>
-              <a:t/>
-            </a:r>
             <a:endParaRPr lang="en-US" dirty="0"/>
           </a:p>
         </p:txBody>
@@ -1301,10 +1155,6 @@
           <a:bodyPr/>
           <a:lstStyle/>
           <a:p>
-            <a:r>
-              <a:rPr lang="en-US" dirty="0"/>
-              <a:t/>
-            </a:r>
             <a:endParaRPr lang="en-US" dirty="0"/>
           </a:p>
         </p:txBody>
@@ -1378,6 +1228,11 @@
 <file path=ppt/slideMasters/slideMaster1.xml><?xml version="1.0" encoding="utf-8"?>
 <p:sldMaster xmlns:a="http://schemas.openxmlformats.org/drawingml/2006/main" xmlns:r="http://schemas.openxmlformats.org/officeDocument/2006/relationships" xmlns:p="http://schemas.openxmlformats.org/presentationml/2006/main">
   <p:cSld>
+    <p:bg>
+      <p:bgRef idx="1001">
+        <a:schemeClr val="bg1"/>
+      </p:bgRef>
+    </p:bg>
     <p:spTree>
       <p:nvGrpSpPr>
         <p:cNvPr id="1" name=""/>
@@ -1660,6 +1515,7 @@
         <a:solidFill>
           <a:srgbClr val="0E1117"/>
         </a:solidFill>
+        <a:effectLst/>
       </p:bgPr>
     </p:bg>
     <p:spTree>
@@ -1717,11 +1573,11 @@
           <a:bodyPr wrap="square" rtlCol="0" anchor="ctr"/>
           <a:lstStyle/>
           <a:p>
-            <a:pPr indent="0" marL="0">
-              <a:buNone/>
-            </a:pPr>
-            <a:r>
-              <a:rPr lang="en-US" sz="1300" b="1" spc="600" kern="0" dirty="0">
+            <a:pPr marL="0" indent="0">
+              <a:buNone/>
+            </a:pPr>
+            <a:r>
+              <a:rPr lang="en-US" sz="1300" b="1" kern="0" spc="600" dirty="0">
                 <a:solidFill>
                   <a:srgbClr val="8A93A6"/>
                 </a:solidFill>
@@ -1756,7 +1612,7 @@
           <a:bodyPr wrap="square" rtlCol="0" anchor="ctr"/>
           <a:lstStyle/>
           <a:p>
-            <a:pPr indent="0" marL="0">
+            <a:pPr marL="0" indent="0">
               <a:buNone/>
             </a:pPr>
             <a:r>
@@ -1795,7 +1651,7 @@
           <a:bodyPr wrap="square" rtlCol="0" anchor="ctr"/>
           <a:lstStyle/>
           <a:p>
-            <a:pPr indent="0" marL="0">
+            <a:pPr marL="0" indent="0">
               <a:lnSpc>
                 <a:spcPct val="120000"/>
               </a:lnSpc>
@@ -1815,7 +1671,7 @@
             <a:endParaRPr lang="en-US" sz="1700" dirty="0"/>
           </a:p>
           <a:p>
-            <a:pPr indent="0" marL="0">
+            <a:pPr marL="0" indent="0">
               <a:lnSpc>
                 <a:spcPct val="120000"/>
               </a:lnSpc>
@@ -1877,7 +1733,7 @@
           <a:bodyPr wrap="square" rtlCol="0" anchor="ctr"/>
           <a:lstStyle/>
           <a:p>
-            <a:pPr indent="0" marL="0">
+            <a:pPr marL="0" indent="0">
               <a:buNone/>
             </a:pPr>
             <a:r>
@@ -1936,7 +1792,7 @@
           <a:bodyPr wrap="square" rtlCol="0" anchor="ctr"/>
           <a:lstStyle/>
           <a:p>
-            <a:pPr indent="0" marL="0">
+            <a:pPr marL="0" indent="0">
               <a:buNone/>
             </a:pPr>
             <a:r>
@@ -1995,7 +1851,7 @@
           <a:bodyPr wrap="square" rtlCol="0" anchor="ctr"/>
           <a:lstStyle/>
           <a:p>
-            <a:pPr indent="0" marL="0">
+            <a:pPr marL="0" indent="0">
               <a:buNone/>
             </a:pPr>
             <a:r>
@@ -2054,7 +1910,7 @@
           <a:bodyPr wrap="square" rtlCol="0" anchor="ctr"/>
           <a:lstStyle/>
           <a:p>
-            <a:pPr indent="0" marL="0">
+            <a:pPr marL="0" indent="0">
               <a:buNone/>
             </a:pPr>
             <a:r>
@@ -2088,6 +1944,7 @@
         <a:solidFill>
           <a:srgbClr val="0E1117"/>
         </a:solidFill>
+        <a:effectLst/>
       </p:bgPr>
     </p:bg>
     <p:spTree>
@@ -2145,11 +2002,11 @@
           <a:bodyPr wrap="square" rtlCol="0" anchor="ctr"/>
           <a:lstStyle/>
           <a:p>
-            <a:pPr indent="0" marL="0">
-              <a:buNone/>
-            </a:pPr>
-            <a:r>
-              <a:rPr lang="en-US" sz="1100" b="1" spc="500" kern="0" dirty="0">
+            <a:pPr marL="0" indent="0">
+              <a:buNone/>
+            </a:pPr>
+            <a:r>
+              <a:rPr lang="en-US" sz="1100" b="1" kern="0" spc="500" dirty="0">
                 <a:solidFill>
                   <a:srgbClr val="8A93A6"/>
                 </a:solidFill>
@@ -2184,7 +2041,7 @@
           <a:bodyPr wrap="square" rtlCol="0" anchor="ctr"/>
           <a:lstStyle/>
           <a:p>
-            <a:pPr indent="0" marL="0">
+            <a:pPr marL="0" indent="0">
               <a:buNone/>
             </a:pPr>
             <a:r>
@@ -2250,7 +2107,7 @@
           <a:bodyPr wrap="square" rtlCol="0" anchor="ctr"/>
           <a:lstStyle/>
           <a:p>
-            <a:pPr indent="0" marL="0">
+            <a:pPr marL="0" indent="0">
               <a:buNone/>
             </a:pPr>
             <a:r>
@@ -2289,7 +2146,7 @@
           <a:bodyPr wrap="square" rtlCol="0" anchor="ctr"/>
           <a:lstStyle/>
           <a:p>
-            <a:pPr indent="0" marL="0">
+            <a:pPr marL="0" indent="0">
               <a:lnSpc>
                 <a:spcPct val="110000"/>
               </a:lnSpc>
@@ -2358,7 +2215,7 @@
           <a:bodyPr wrap="square" rtlCol="0" anchor="ctr"/>
           <a:lstStyle/>
           <a:p>
-            <a:pPr indent="0" marL="0">
+            <a:pPr marL="0" indent="0">
               <a:buNone/>
             </a:pPr>
             <a:r>
@@ -2397,7 +2254,7 @@
           <a:bodyPr wrap="square" rtlCol="0" anchor="ctr"/>
           <a:lstStyle/>
           <a:p>
-            <a:pPr indent="0" marL="0">
+            <a:pPr marL="0" indent="0">
               <a:lnSpc>
                 <a:spcPct val="110000"/>
               </a:lnSpc>
@@ -2466,7 +2323,7 @@
           <a:bodyPr wrap="square" rtlCol="0" anchor="ctr"/>
           <a:lstStyle/>
           <a:p>
-            <a:pPr indent="0" marL="0">
+            <a:pPr marL="0" indent="0">
               <a:buNone/>
             </a:pPr>
             <a:r>
@@ -2505,7 +2362,7 @@
           <a:bodyPr wrap="square" rtlCol="0" anchor="ctr"/>
           <a:lstStyle/>
           <a:p>
-            <a:pPr indent="0" marL="0">
+            <a:pPr marL="0" indent="0">
               <a:lnSpc>
                 <a:spcPct val="110000"/>
               </a:lnSpc>
@@ -2574,7 +2431,7 @@
           <a:bodyPr wrap="square" rtlCol="0" anchor="ctr"/>
           <a:lstStyle/>
           <a:p>
-            <a:pPr indent="0" marL="0">
+            <a:pPr marL="0" indent="0">
               <a:buNone/>
             </a:pPr>
             <a:r>
@@ -2613,7 +2470,7 @@
           <a:bodyPr wrap="square" rtlCol="0" anchor="ctr"/>
           <a:lstStyle/>
           <a:p>
-            <a:pPr indent="0" marL="0">
+            <a:pPr marL="0" indent="0">
               <a:lnSpc>
                 <a:spcPct val="110000"/>
               </a:lnSpc>
@@ -2655,7 +2512,7 @@
           <a:bodyPr wrap="square" rtlCol="0" anchor="ctr"/>
           <a:lstStyle/>
           <a:p>
-            <a:pPr indent="0" marL="0">
+            <a:pPr marL="0" indent="0">
               <a:lnSpc>
                 <a:spcPct val="120000"/>
               </a:lnSpc>
@@ -2697,7 +2554,7 @@
           <a:bodyPr wrap="square" rtlCol="0" anchor="ctr"/>
           <a:lstStyle/>
           <a:p>
-            <a:pPr indent="0" marL="0">
+            <a:pPr marL="0" indent="0">
               <a:lnSpc>
                 <a:spcPct val="120000"/>
               </a:lnSpc>
@@ -2719,6 +2576,270 @@
         </p:txBody>
       </p:sp>
     </p:spTree>
+  </p:cSld>
+  <p:clrMapOvr>
+    <a:masterClrMapping/>
+  </p:clrMapOvr>
+</p:sld>
+</file>
+
+<file path=ppt/slides/slide11.xml><?xml version="1.0" encoding="utf-8"?>
+<p:sld xmlns:a="http://schemas.openxmlformats.org/drawingml/2006/main" xmlns:r="http://schemas.openxmlformats.org/officeDocument/2006/relationships" xmlns:p="http://schemas.openxmlformats.org/presentationml/2006/main">
+  <p:cSld>
+    <p:bg>
+      <p:bgPr>
+        <a:solidFill>
+          <a:srgbClr val="0E1117"/>
+        </a:solidFill>
+        <a:effectLst/>
+      </p:bgPr>
+    </p:bg>
+    <p:spTree>
+      <p:nvGrpSpPr>
+        <p:cNvPr id="1" name="">
+          <a:extLst>
+            <a:ext uri="{FF2B5EF4-FFF2-40B4-BE49-F238E27FC236}">
+              <a16:creationId xmlns:a16="http://schemas.microsoft.com/office/drawing/2014/main" id="{640D6C63-C001-BC56-D426-AACD1617AA85}"/>
+            </a:ext>
+          </a:extLst>
+        </p:cNvPr>
+        <p:cNvGrpSpPr/>
+        <p:nvPr/>
+      </p:nvGrpSpPr>
+      <p:grpSpPr>
+        <a:xfrm>
+          <a:off x="0" y="0"/>
+          <a:ext cx="0" cy="0"/>
+          <a:chOff x="0" y="0"/>
+          <a:chExt cx="0" cy="0"/>
+        </a:xfrm>
+      </p:grpSpPr>
+      <p:sp>
+        <p:nvSpPr>
+          <p:cNvPr id="2" name="Shape 0">
+            <a:extLst>
+              <a:ext uri="{FF2B5EF4-FFF2-40B4-BE49-F238E27FC236}">
+                <a16:creationId xmlns:a16="http://schemas.microsoft.com/office/drawing/2014/main" id="{C52D62E4-0CFF-33BD-F42C-A3A4625D6FA8}"/>
+              </a:ext>
+            </a:extLst>
+          </p:cNvPr>
+          <p:cNvSpPr/>
+          <p:nvPr/>
+        </p:nvSpPr>
+        <p:spPr>
+          <a:xfrm>
+            <a:off x="0" y="0"/>
+            <a:ext cx="12161520" cy="109728"/>
+          </a:xfrm>
+          <a:prstGeom prst="rect">
+            <a:avLst/>
+          </a:prstGeom>
+          <a:solidFill>
+            <a:srgbClr val="F6C445"/>
+          </a:solidFill>
+          <a:ln/>
+        </p:spPr>
+      </p:sp>
+      <p:sp>
+        <p:nvSpPr>
+          <p:cNvPr id="3" name="Text 1">
+            <a:extLst>
+              <a:ext uri="{FF2B5EF4-FFF2-40B4-BE49-F238E27FC236}">
+                <a16:creationId xmlns:a16="http://schemas.microsoft.com/office/drawing/2014/main" id="{EDFE956E-1F8A-C930-5812-2838C6A37D4B}"/>
+              </a:ext>
+            </a:extLst>
+          </p:cNvPr>
+          <p:cNvSpPr/>
+          <p:nvPr/>
+        </p:nvSpPr>
+        <p:spPr>
+          <a:xfrm>
+            <a:off x="548640" y="365760"/>
+            <a:ext cx="10972800" cy="274320"/>
+          </a:xfrm>
+          <a:prstGeom prst="rect">
+            <a:avLst/>
+          </a:prstGeom>
+          <a:noFill/>
+          <a:ln/>
+        </p:spPr>
+        <p:txBody>
+          <a:bodyPr wrap="square" rtlCol="0" anchor="ctr"/>
+          <a:lstStyle/>
+          <a:p>
+            <a:pPr marL="0" indent="0">
+              <a:buNone/>
+            </a:pPr>
+            <a:r>
+              <a:rPr lang="en-US" sz="1100" b="1" kern="0" spc="500" dirty="0">
+                <a:solidFill>
+                  <a:srgbClr val="8A93A6"/>
+                </a:solidFill>
+                <a:latin typeface="Calibri" pitchFamily="34" charset="0"/>
+                <a:ea typeface="Calibri" pitchFamily="34" charset="-122"/>
+                <a:cs typeface="Calibri" pitchFamily="34" charset="-120"/>
+              </a:rPr>
+              <a:t>10: REPO LINK &amp; STREAMLIT LINK</a:t>
+            </a:r>
+            <a:endParaRPr lang="en-US" sz="1100" dirty="0"/>
+          </a:p>
+        </p:txBody>
+      </p:sp>
+      <p:sp>
+        <p:nvSpPr>
+          <p:cNvPr id="4" name="Text 2">
+            <a:extLst>
+              <a:ext uri="{FF2B5EF4-FFF2-40B4-BE49-F238E27FC236}">
+                <a16:creationId xmlns:a16="http://schemas.microsoft.com/office/drawing/2014/main" id="{D787E921-6AF1-6A0D-AD42-5C7BEA4C321F}"/>
+              </a:ext>
+            </a:extLst>
+          </p:cNvPr>
+          <p:cNvSpPr/>
+          <p:nvPr/>
+        </p:nvSpPr>
+        <p:spPr>
+          <a:xfrm>
+            <a:off x="548640" y="1752600"/>
+            <a:ext cx="11064240" cy="3429000"/>
+          </a:xfrm>
+          <a:prstGeom prst="rect">
+            <a:avLst/>
+          </a:prstGeom>
+          <a:noFill/>
+          <a:ln/>
+        </p:spPr>
+        <p:txBody>
+          <a:bodyPr wrap="square" rtlCol="0" anchor="ctr"/>
+          <a:lstStyle/>
+          <a:p>
+            <a:r>
+              <a:rPr lang="en-US" sz="3400" b="1" dirty="0">
+                <a:solidFill>
+                  <a:srgbClr val="F2F4F8"/>
+                </a:solidFill>
+                <a:latin typeface="Cambria" pitchFamily="34" charset="0"/>
+                <a:ea typeface="Cambria" pitchFamily="34" charset="-122"/>
+                <a:cs typeface="Cambria" pitchFamily="34" charset="-120"/>
+              </a:rPr>
+              <a:t>Repo Link:</a:t>
+            </a:r>
+            <a:br>
+              <a:rPr lang="en-US" sz="3400" b="1" dirty="0">
+                <a:solidFill>
+                  <a:srgbClr val="F2F4F8"/>
+                </a:solidFill>
+                <a:latin typeface="Cambria" pitchFamily="34" charset="0"/>
+                <a:ea typeface="Cambria" pitchFamily="34" charset="-122"/>
+                <a:cs typeface="Cambria" pitchFamily="34" charset="-120"/>
+              </a:rPr>
+            </a:br>
+            <a:r>
+              <a:rPr lang="en-US" sz="3400" b="1" dirty="0">
+                <a:solidFill>
+                  <a:srgbClr val="F2F4F8"/>
+                </a:solidFill>
+                <a:latin typeface="Cambria" pitchFamily="34" charset="0"/>
+                <a:ea typeface="Cambria" pitchFamily="34" charset="-122"/>
+                <a:cs typeface="Cambria" pitchFamily="34" charset="-120"/>
+                <a:hlinkClick r:id="rId3"/>
+              </a:rPr>
+              <a:t>https://github.com/rd51/smartgrid</a:t>
+            </a:r>
+            <a:endParaRPr lang="en-US" sz="3400" b="1" dirty="0">
+              <a:solidFill>
+                <a:srgbClr val="F2F4F8"/>
+              </a:solidFill>
+              <a:latin typeface="Cambria" pitchFamily="34" charset="0"/>
+              <a:ea typeface="Cambria" pitchFamily="34" charset="-122"/>
+              <a:cs typeface="Cambria" pitchFamily="34" charset="-120"/>
+            </a:endParaRPr>
+          </a:p>
+          <a:p>
+            <a:endParaRPr lang="en-US" sz="3400" b="1" dirty="0">
+              <a:solidFill>
+                <a:srgbClr val="F2F4F8"/>
+              </a:solidFill>
+              <a:latin typeface="Cambria" pitchFamily="34" charset="0"/>
+              <a:ea typeface="Cambria" pitchFamily="34" charset="-122"/>
+              <a:cs typeface="Cambria" pitchFamily="34" charset="-120"/>
+            </a:endParaRPr>
+          </a:p>
+          <a:p>
+            <a:r>
+              <a:rPr lang="en-US" sz="3400" b="1" dirty="0" err="1">
+                <a:solidFill>
+                  <a:srgbClr val="F2F4F8"/>
+                </a:solidFill>
+                <a:latin typeface="Cambria" pitchFamily="34" charset="0"/>
+                <a:ea typeface="Cambria" pitchFamily="34" charset="-122"/>
+                <a:cs typeface="Cambria" pitchFamily="34" charset="-120"/>
+              </a:rPr>
+              <a:t>Streamlit</a:t>
+            </a:r>
+            <a:r>
+              <a:rPr lang="en-US" sz="3400" b="1" dirty="0">
+                <a:solidFill>
+                  <a:srgbClr val="F2F4F8"/>
+                </a:solidFill>
+                <a:latin typeface="Cambria" pitchFamily="34" charset="0"/>
+                <a:ea typeface="Cambria" pitchFamily="34" charset="-122"/>
+                <a:cs typeface="Cambria" pitchFamily="34" charset="-120"/>
+              </a:rPr>
+              <a:t> Link:</a:t>
+            </a:r>
+          </a:p>
+          <a:p>
+            <a:r>
+              <a:rPr lang="en-US" sz="3400" b="1" dirty="0">
+                <a:solidFill>
+                  <a:srgbClr val="F2F4F8"/>
+                </a:solidFill>
+                <a:latin typeface="Cambria" pitchFamily="34" charset="0"/>
+                <a:ea typeface="Cambria" pitchFamily="34" charset="-122"/>
+                <a:cs typeface="Cambria" pitchFamily="34" charset="-120"/>
+                <a:hlinkClick r:id="rId4"/>
+              </a:rPr>
+              <a:t>https://smartgrid-e2ravxbaczgefysvkuoa4m.streamlit.app/</a:t>
+            </a:r>
+            <a:endParaRPr lang="en-US" sz="3400" b="1" dirty="0">
+              <a:solidFill>
+                <a:srgbClr val="F2F4F8"/>
+              </a:solidFill>
+              <a:latin typeface="Cambria" pitchFamily="34" charset="0"/>
+              <a:ea typeface="Cambria" pitchFamily="34" charset="-122"/>
+              <a:cs typeface="Cambria" pitchFamily="34" charset="-120"/>
+            </a:endParaRPr>
+          </a:p>
+          <a:p>
+            <a:endParaRPr lang="en-US" sz="3400" b="1" dirty="0">
+              <a:solidFill>
+                <a:srgbClr val="F2F4F8"/>
+              </a:solidFill>
+              <a:latin typeface="Cambria" pitchFamily="34" charset="0"/>
+              <a:ea typeface="Cambria" pitchFamily="34" charset="-122"/>
+              <a:cs typeface="Cambria" pitchFamily="34" charset="-120"/>
+            </a:endParaRPr>
+          </a:p>
+          <a:p>
+            <a:endParaRPr lang="en-US" sz="3400" b="1" dirty="0">
+              <a:solidFill>
+                <a:srgbClr val="F2F4F8"/>
+              </a:solidFill>
+              <a:latin typeface="Cambria" pitchFamily="34" charset="0"/>
+              <a:ea typeface="Cambria" pitchFamily="34" charset="-122"/>
+            </a:endParaRPr>
+          </a:p>
+          <a:p>
+            <a:endParaRPr lang="en-US" sz="3400" dirty="0"/>
+          </a:p>
+        </p:txBody>
+      </p:sp>
+    </p:spTree>
+    <p:extLst>
+      <p:ext uri="{BB962C8B-B14F-4D97-AF65-F5344CB8AC3E}">
+        <p14:creationId xmlns:p14="http://schemas.microsoft.com/office/powerpoint/2010/main" val="4080408817"/>
+      </p:ext>
+    </p:extLst>
   </p:cSld>
   <p:clrMapOvr>
     <a:masterClrMapping/>
@@ -2734,6 +2855,7 @@
         <a:solidFill>
           <a:srgbClr val="0E1117"/>
         </a:solidFill>
+        <a:effectLst/>
       </p:bgPr>
     </p:bg>
     <p:spTree>
@@ -2771,11 +2893,11 @@
           <a:bodyPr wrap="square" rtlCol="0" anchor="ctr"/>
           <a:lstStyle/>
           <a:p>
-            <a:pPr indent="0" marL="0">
-              <a:buNone/>
-            </a:pPr>
-            <a:r>
-              <a:rPr lang="en-US" sz="1100" b="1" spc="500" kern="0" dirty="0">
+            <a:pPr marL="0" indent="0">
+              <a:buNone/>
+            </a:pPr>
+            <a:r>
+              <a:rPr lang="en-US" sz="1100" b="1" kern="0" spc="500" dirty="0">
                 <a:solidFill>
                   <a:srgbClr val="8A93A6"/>
                 </a:solidFill>
@@ -2810,7 +2932,7 @@
           <a:bodyPr wrap="square" rtlCol="0" anchor="ctr"/>
           <a:lstStyle/>
           <a:p>
-            <a:pPr indent="0" marL="0">
+            <a:pPr marL="0" indent="0">
               <a:buNone/>
             </a:pPr>
             <a:r>
@@ -2896,7 +3018,7 @@
           <a:bodyPr wrap="square" rtlCol="0" anchor="ctr"/>
           <a:lstStyle/>
           <a:p>
-            <a:pPr indent="0" marL="0">
+            <a:pPr marL="0" indent="0">
               <a:buNone/>
             </a:pPr>
             <a:r>
@@ -2935,7 +3057,7 @@
           <a:bodyPr wrap="square" rtlCol="0" anchor="ctr"/>
           <a:lstStyle/>
           <a:p>
-            <a:pPr indent="0" marL="0">
+            <a:pPr marL="0" indent="0">
               <a:lnSpc>
                 <a:spcPct val="115000"/>
               </a:lnSpc>
@@ -3024,7 +3146,7 @@
           <a:bodyPr wrap="square" rtlCol="0" anchor="ctr"/>
           <a:lstStyle/>
           <a:p>
-            <a:pPr indent="0" marL="0">
+            <a:pPr marL="0" indent="0">
               <a:buNone/>
             </a:pPr>
             <a:r>
@@ -3063,7 +3185,7 @@
           <a:bodyPr wrap="square" rtlCol="0" anchor="ctr"/>
           <a:lstStyle/>
           <a:p>
-            <a:pPr indent="0" marL="0">
+            <a:pPr marL="0" indent="0">
               <a:lnSpc>
                 <a:spcPct val="115000"/>
               </a:lnSpc>
@@ -3152,7 +3274,7 @@
           <a:bodyPr wrap="square" rtlCol="0" anchor="ctr"/>
           <a:lstStyle/>
           <a:p>
-            <a:pPr indent="0" marL="0">
+            <a:pPr marL="0" indent="0">
               <a:buNone/>
             </a:pPr>
             <a:r>
@@ -3191,7 +3313,7 @@
           <a:bodyPr wrap="square" rtlCol="0" anchor="ctr"/>
           <a:lstStyle/>
           <a:p>
-            <a:pPr indent="0" marL="0">
+            <a:pPr marL="0" indent="0">
               <a:lnSpc>
                 <a:spcPct val="115000"/>
               </a:lnSpc>
@@ -3280,7 +3402,7 @@
           <a:bodyPr wrap="square" rtlCol="0" anchor="ctr"/>
           <a:lstStyle/>
           <a:p>
-            <a:pPr indent="0" marL="0">
+            <a:pPr marL="0" indent="0">
               <a:buNone/>
             </a:pPr>
             <a:r>
@@ -3319,7 +3441,7 @@
           <a:bodyPr wrap="square" rtlCol="0" anchor="ctr"/>
           <a:lstStyle/>
           <a:p>
-            <a:pPr indent="0" marL="0">
+            <a:pPr marL="0" indent="0">
               <a:lnSpc>
                 <a:spcPct val="115000"/>
               </a:lnSpc>
@@ -3356,6 +3478,7 @@
         <a:solidFill>
           <a:srgbClr val="0E1117"/>
         </a:solidFill>
+        <a:effectLst/>
       </p:bgPr>
     </p:bg>
     <p:spTree>
@@ -3393,11 +3516,11 @@
           <a:bodyPr wrap="square" rtlCol="0" anchor="ctr"/>
           <a:lstStyle/>
           <a:p>
-            <a:pPr indent="0" marL="0">
-              <a:buNone/>
-            </a:pPr>
-            <a:r>
-              <a:rPr lang="en-US" sz="1100" b="1" spc="500" kern="0" dirty="0">
+            <a:pPr marL="0" indent="0">
+              <a:buNone/>
+            </a:pPr>
+            <a:r>
+              <a:rPr lang="en-US" sz="1100" b="1" kern="0" spc="500" dirty="0">
                 <a:solidFill>
                   <a:srgbClr val="8A93A6"/>
                 </a:solidFill>
@@ -3432,7 +3555,7 @@
           <a:bodyPr wrap="square" rtlCol="0" anchor="ctr"/>
           <a:lstStyle/>
           <a:p>
-            <a:pPr indent="0" marL="0">
+            <a:pPr marL="0" indent="0">
               <a:buNone/>
             </a:pPr>
             <a:r>
@@ -3518,7 +3641,7 @@
           <a:bodyPr wrap="square" rtlCol="0" anchor="ctr"/>
           <a:lstStyle/>
           <a:p>
-            <a:pPr algn="ctr" indent="0" marL="0">
+            <a:pPr marL="0" indent="0" algn="ctr">
               <a:buNone/>
             </a:pPr>
             <a:r>
@@ -3557,7 +3680,7 @@
           <a:bodyPr wrap="square" rtlCol="0" anchor="ctr"/>
           <a:lstStyle/>
           <a:p>
-            <a:pPr indent="0" marL="0">
+            <a:pPr marL="0" indent="0">
               <a:buNone/>
             </a:pPr>
             <a:r>
@@ -3596,7 +3719,7 @@
           <a:bodyPr wrap="square" rtlCol="0" anchor="ctr"/>
           <a:lstStyle/>
           <a:p>
-            <a:pPr indent="0" marL="0">
+            <a:pPr marL="0" indent="0">
               <a:lnSpc>
                 <a:spcPct val="110000"/>
               </a:lnSpc>
@@ -3685,7 +3808,7 @@
           <a:bodyPr wrap="square" rtlCol="0" anchor="ctr"/>
           <a:lstStyle/>
           <a:p>
-            <a:pPr algn="ctr" indent="0" marL="0">
+            <a:pPr marL="0" indent="0" algn="ctr">
               <a:buNone/>
             </a:pPr>
             <a:r>
@@ -3724,7 +3847,7 @@
           <a:bodyPr wrap="square" rtlCol="0" anchor="ctr"/>
           <a:lstStyle/>
           <a:p>
-            <a:pPr indent="0" marL="0">
+            <a:pPr marL="0" indent="0">
               <a:buNone/>
             </a:pPr>
             <a:r>
@@ -3763,7 +3886,7 @@
           <a:bodyPr wrap="square" rtlCol="0" anchor="ctr"/>
           <a:lstStyle/>
           <a:p>
-            <a:pPr indent="0" marL="0">
+            <a:pPr marL="0" indent="0">
               <a:lnSpc>
                 <a:spcPct val="110000"/>
               </a:lnSpc>
@@ -3852,7 +3975,7 @@
           <a:bodyPr wrap="square" rtlCol="0" anchor="ctr"/>
           <a:lstStyle/>
           <a:p>
-            <a:pPr algn="ctr" indent="0" marL="0">
+            <a:pPr marL="0" indent="0" algn="ctr">
               <a:buNone/>
             </a:pPr>
             <a:r>
@@ -3891,7 +4014,7 @@
           <a:bodyPr wrap="square" rtlCol="0" anchor="ctr"/>
           <a:lstStyle/>
           <a:p>
-            <a:pPr indent="0" marL="0">
+            <a:pPr marL="0" indent="0">
               <a:buNone/>
             </a:pPr>
             <a:r>
@@ -3930,7 +4053,7 @@
           <a:bodyPr wrap="square" rtlCol="0" anchor="ctr"/>
           <a:lstStyle/>
           <a:p>
-            <a:pPr indent="0" marL="0">
+            <a:pPr marL="0" indent="0">
               <a:lnSpc>
                 <a:spcPct val="110000"/>
               </a:lnSpc>
@@ -4019,7 +4142,7 @@
           <a:bodyPr wrap="square" rtlCol="0" anchor="ctr"/>
           <a:lstStyle/>
           <a:p>
-            <a:pPr algn="ctr" indent="0" marL="0">
+            <a:pPr marL="0" indent="0" algn="ctr">
               <a:buNone/>
             </a:pPr>
             <a:r>
@@ -4058,7 +4181,7 @@
           <a:bodyPr wrap="square" rtlCol="0" anchor="ctr"/>
           <a:lstStyle/>
           <a:p>
-            <a:pPr indent="0" marL="0">
+            <a:pPr marL="0" indent="0">
               <a:buNone/>
             </a:pPr>
             <a:r>
@@ -4097,7 +4220,7 @@
           <a:bodyPr wrap="square" rtlCol="0" anchor="ctr"/>
           <a:lstStyle/>
           <a:p>
-            <a:pPr indent="0" marL="0">
+            <a:pPr marL="0" indent="0">
               <a:lnSpc>
                 <a:spcPct val="110000"/>
               </a:lnSpc>
@@ -4139,7 +4262,7 @@
           <a:bodyPr wrap="square" rtlCol="0" anchor="ctr"/>
           <a:lstStyle/>
           <a:p>
-            <a:pPr indent="0" marL="0">
+            <a:pPr marL="0" indent="0">
               <a:buNone/>
             </a:pPr>
             <a:r>
@@ -4173,6 +4296,7 @@
         <a:solidFill>
           <a:srgbClr val="0E1117"/>
         </a:solidFill>
+        <a:effectLst/>
       </p:bgPr>
     </p:bg>
     <p:spTree>
@@ -4210,11 +4334,11 @@
           <a:bodyPr wrap="square" rtlCol="0" anchor="ctr"/>
           <a:lstStyle/>
           <a:p>
-            <a:pPr indent="0" marL="0">
-              <a:buNone/>
-            </a:pPr>
-            <a:r>
-              <a:rPr lang="en-US" sz="1100" b="1" spc="500" kern="0" dirty="0">
+            <a:pPr marL="0" indent="0">
+              <a:buNone/>
+            </a:pPr>
+            <a:r>
+              <a:rPr lang="en-US" sz="1100" b="1" kern="0" spc="500" dirty="0">
                 <a:solidFill>
                   <a:srgbClr val="8A93A6"/>
                 </a:solidFill>
@@ -4249,7 +4373,7 @@
           <a:bodyPr wrap="square" rtlCol="0" anchor="ctr"/>
           <a:lstStyle/>
           <a:p>
-            <a:pPr indent="0" marL="0">
+            <a:pPr marL="0" indent="0">
               <a:buNone/>
             </a:pPr>
             <a:r>
@@ -4335,7 +4459,7 @@
           <a:bodyPr wrap="square" rtlCol="0" anchor="ctr"/>
           <a:lstStyle/>
           <a:p>
-            <a:pPr indent="0" marL="0">
+            <a:pPr marL="0" indent="0">
               <a:buNone/>
             </a:pPr>
             <a:r>
@@ -4374,7 +4498,7 @@
           <a:bodyPr wrap="square" rtlCol="0" anchor="ctr"/>
           <a:lstStyle/>
           <a:p>
-            <a:pPr indent="0" marL="0">
+            <a:pPr marL="0" indent="0">
               <a:lnSpc>
                 <a:spcPct val="105000"/>
               </a:lnSpc>
@@ -4416,7 +4540,7 @@
           <a:bodyPr wrap="square" rtlCol="0" anchor="ctr"/>
           <a:lstStyle/>
           <a:p>
-            <a:pPr algn="ctr" indent="0" marL="0">
+            <a:pPr marL="0" indent="0" algn="ctr">
               <a:buNone/>
             </a:pPr>
             <a:r>
@@ -4502,7 +4626,7 @@
           <a:bodyPr wrap="square" rtlCol="0" anchor="ctr"/>
           <a:lstStyle/>
           <a:p>
-            <a:pPr indent="0" marL="0">
+            <a:pPr marL="0" indent="0">
               <a:buNone/>
             </a:pPr>
             <a:r>
@@ -4541,7 +4665,7 @@
           <a:bodyPr wrap="square" rtlCol="0" anchor="ctr"/>
           <a:lstStyle/>
           <a:p>
-            <a:pPr indent="0" marL="0">
+            <a:pPr marL="0" indent="0">
               <a:lnSpc>
                 <a:spcPct val="105000"/>
               </a:lnSpc>
@@ -4583,7 +4707,7 @@
           <a:bodyPr wrap="square" rtlCol="0" anchor="ctr"/>
           <a:lstStyle/>
           <a:p>
-            <a:pPr algn="ctr" indent="0" marL="0">
+            <a:pPr marL="0" indent="0" algn="ctr">
               <a:buNone/>
             </a:pPr>
             <a:r>
@@ -4669,7 +4793,7 @@
           <a:bodyPr wrap="square" rtlCol="0" anchor="ctr"/>
           <a:lstStyle/>
           <a:p>
-            <a:pPr indent="0" marL="0">
+            <a:pPr marL="0" indent="0">
               <a:buNone/>
             </a:pPr>
             <a:r>
@@ -4708,7 +4832,7 @@
           <a:bodyPr wrap="square" rtlCol="0" anchor="ctr"/>
           <a:lstStyle/>
           <a:p>
-            <a:pPr indent="0" marL="0">
+            <a:pPr marL="0" indent="0">
               <a:lnSpc>
                 <a:spcPct val="105000"/>
               </a:lnSpc>
@@ -4750,7 +4874,7 @@
           <a:bodyPr wrap="square" rtlCol="0" anchor="ctr"/>
           <a:lstStyle/>
           <a:p>
-            <a:pPr algn="ctr" indent="0" marL="0">
+            <a:pPr marL="0" indent="0" algn="ctr">
               <a:buNone/>
             </a:pPr>
             <a:r>
@@ -4836,7 +4960,7 @@
           <a:bodyPr wrap="square" rtlCol="0" anchor="ctr"/>
           <a:lstStyle/>
           <a:p>
-            <a:pPr indent="0" marL="0">
+            <a:pPr marL="0" indent="0">
               <a:buNone/>
             </a:pPr>
             <a:r>
@@ -4875,7 +4999,7 @@
           <a:bodyPr wrap="square" rtlCol="0" anchor="ctr"/>
           <a:lstStyle/>
           <a:p>
-            <a:pPr indent="0" marL="0">
+            <a:pPr marL="0" indent="0">
               <a:lnSpc>
                 <a:spcPct val="105000"/>
               </a:lnSpc>
@@ -4917,7 +5041,7 @@
           <a:bodyPr wrap="square" rtlCol="0" anchor="ctr"/>
           <a:lstStyle/>
           <a:p>
-            <a:pPr algn="ctr" indent="0" marL="0">
+            <a:pPr marL="0" indent="0" algn="ctr">
               <a:buNone/>
             </a:pPr>
             <a:r>
@@ -5003,7 +5127,7 @@
           <a:bodyPr wrap="square" rtlCol="0" anchor="ctr"/>
           <a:lstStyle/>
           <a:p>
-            <a:pPr indent="0" marL="0">
+            <a:pPr marL="0" indent="0">
               <a:buNone/>
             </a:pPr>
             <a:r>
@@ -5042,7 +5166,7 @@
           <a:bodyPr wrap="square" rtlCol="0" anchor="ctr"/>
           <a:lstStyle/>
           <a:p>
-            <a:pPr indent="0" marL="0">
+            <a:pPr marL="0" indent="0">
               <a:lnSpc>
                 <a:spcPct val="105000"/>
               </a:lnSpc>
@@ -5084,7 +5208,7 @@
           <a:bodyPr wrap="square" rtlCol="0" anchor="ctr"/>
           <a:lstStyle/>
           <a:p>
-            <a:pPr indent="0" marL="0">
+            <a:pPr marL="0" indent="0">
               <a:buNone/>
             </a:pPr>
             <a:r>
@@ -5118,6 +5242,7 @@
         <a:solidFill>
           <a:srgbClr val="0E1117"/>
         </a:solidFill>
+        <a:effectLst/>
       </p:bgPr>
     </p:bg>
     <p:spTree>
@@ -5155,11 +5280,11 @@
           <a:bodyPr wrap="square" rtlCol="0" anchor="ctr"/>
           <a:lstStyle/>
           <a:p>
-            <a:pPr indent="0" marL="0">
-              <a:buNone/>
-            </a:pPr>
-            <a:r>
-              <a:rPr lang="en-US" sz="1100" b="1" spc="500" kern="0" dirty="0">
+            <a:pPr marL="0" indent="0">
+              <a:buNone/>
+            </a:pPr>
+            <a:r>
+              <a:rPr lang="en-US" sz="1100" b="1" kern="0" spc="500" dirty="0">
                 <a:solidFill>
                   <a:srgbClr val="8A93A6"/>
                 </a:solidFill>
@@ -5194,7 +5319,7 @@
           <a:bodyPr wrap="square" rtlCol="0" anchor="ctr"/>
           <a:lstStyle/>
           <a:p>
-            <a:pPr indent="0" marL="0">
+            <a:pPr marL="0" indent="0">
               <a:buNone/>
             </a:pPr>
             <a:r>
@@ -5280,7 +5405,7 @@
           <a:bodyPr wrap="square" rtlCol="0" anchor="ctr"/>
           <a:lstStyle/>
           <a:p>
-            <a:pPr indent="0" marL="0">
+            <a:pPr marL="0" indent="0">
               <a:buNone/>
             </a:pPr>
             <a:r>
@@ -5319,7 +5444,7 @@
           <a:bodyPr wrap="square" rtlCol="0" anchor="ctr"/>
           <a:lstStyle/>
           <a:p>
-            <a:pPr indent="0" marL="0">
+            <a:pPr marL="0" indent="0">
               <a:buNone/>
             </a:pPr>
             <a:r>
@@ -5405,7 +5530,7 @@
           <a:bodyPr wrap="square" rtlCol="0" anchor="ctr"/>
           <a:lstStyle/>
           <a:p>
-            <a:pPr indent="0" marL="0">
+            <a:pPr marL="0" indent="0">
               <a:buNone/>
             </a:pPr>
             <a:r>
@@ -5444,7 +5569,7 @@
           <a:bodyPr wrap="square" rtlCol="0" anchor="ctr"/>
           <a:lstStyle/>
           <a:p>
-            <a:pPr indent="0" marL="0">
+            <a:pPr marL="0" indent="0">
               <a:buNone/>
             </a:pPr>
             <a:r>
@@ -5530,7 +5655,7 @@
           <a:bodyPr wrap="square" rtlCol="0" anchor="ctr"/>
           <a:lstStyle/>
           <a:p>
-            <a:pPr indent="0" marL="0">
+            <a:pPr marL="0" indent="0">
               <a:buNone/>
             </a:pPr>
             <a:r>
@@ -5569,7 +5694,7 @@
           <a:bodyPr wrap="square" rtlCol="0" anchor="ctr"/>
           <a:lstStyle/>
           <a:p>
-            <a:pPr indent="0" marL="0">
+            <a:pPr marL="0" indent="0">
               <a:buNone/>
             </a:pPr>
             <a:r>
@@ -5655,7 +5780,7 @@
           <a:bodyPr wrap="square" rtlCol="0" anchor="ctr"/>
           <a:lstStyle/>
           <a:p>
-            <a:pPr indent="0" marL="0">
+            <a:pPr marL="0" indent="0">
               <a:buNone/>
             </a:pPr>
             <a:r>
@@ -5694,7 +5819,7 @@
           <a:bodyPr wrap="square" rtlCol="0" anchor="ctr"/>
           <a:lstStyle/>
           <a:p>
-            <a:pPr indent="0" marL="0">
+            <a:pPr marL="0" indent="0">
               <a:buNone/>
             </a:pPr>
             <a:r>
@@ -5728,6 +5853,7 @@
         <a:solidFill>
           <a:srgbClr val="0E1117"/>
         </a:solidFill>
+        <a:effectLst/>
       </p:bgPr>
     </p:bg>
     <p:spTree>
@@ -5765,11 +5891,11 @@
           <a:bodyPr wrap="square" rtlCol="0" anchor="ctr"/>
           <a:lstStyle/>
           <a:p>
-            <a:pPr indent="0" marL="0">
-              <a:buNone/>
-            </a:pPr>
-            <a:r>
-              <a:rPr lang="en-US" sz="1100" b="1" spc="500" kern="0" dirty="0">
+            <a:pPr marL="0" indent="0">
+              <a:buNone/>
+            </a:pPr>
+            <a:r>
+              <a:rPr lang="en-US" sz="1100" b="1" kern="0" spc="500" dirty="0">
                 <a:solidFill>
                   <a:srgbClr val="8A93A6"/>
                 </a:solidFill>
@@ -5804,7 +5930,7 @@
           <a:bodyPr wrap="square" rtlCol="0" anchor="ctr"/>
           <a:lstStyle/>
           <a:p>
-            <a:pPr indent="0" marL="0">
+            <a:pPr marL="0" indent="0">
               <a:buNone/>
             </a:pPr>
             <a:r>
@@ -5843,7 +5969,7 @@
           <a:bodyPr wrap="square" rtlCol="0" anchor="ctr"/>
           <a:lstStyle/>
           <a:p>
-            <a:pPr indent="0" marL="0">
+            <a:pPr marL="0" indent="0">
               <a:lnSpc>
                 <a:spcPct val="115000"/>
               </a:lnSpc>
@@ -5860,12 +5986,6 @@
               </a:rPr>
               <a:t>Why synthetic? </a:t>
             </a:r>
-            <a:pPr indent="0" marL="0">
-              <a:lnSpc>
-                <a:spcPct val="115000"/>
-              </a:lnSpc>
-              <a:buNone/>
-            </a:pPr>
             <a:r>
               <a:rPr lang="en-US" sz="1400" dirty="0">
                 <a:solidFill>
@@ -5929,7 +6049,7 @@
           <a:bodyPr wrap="square" rtlCol="0" anchor="ctr"/>
           <a:lstStyle/>
           <a:p>
-            <a:pPr indent="0" marL="0">
+            <a:pPr marL="0" indent="0">
               <a:buNone/>
             </a:pPr>
             <a:r>
@@ -5968,7 +6088,7 @@
           <a:bodyPr wrap="square" rtlCol="0" anchor="ctr"/>
           <a:lstStyle/>
           <a:p>
-            <a:pPr indent="0" marL="0">
+            <a:pPr marL="0" indent="0">
               <a:buNone/>
             </a:pPr>
             <a:r>
@@ -6034,7 +6154,7 @@
           <a:bodyPr wrap="square" rtlCol="0" anchor="ctr"/>
           <a:lstStyle/>
           <a:p>
-            <a:pPr indent="0" marL="0">
+            <a:pPr marL="0" indent="0">
               <a:buNone/>
             </a:pPr>
             <a:r>
@@ -6073,7 +6193,7 @@
           <a:bodyPr wrap="square" rtlCol="0" anchor="ctr"/>
           <a:lstStyle/>
           <a:p>
-            <a:pPr indent="0" marL="0">
+            <a:pPr marL="0" indent="0">
               <a:buNone/>
             </a:pPr>
             <a:r>
@@ -6139,7 +6259,7 @@
           <a:bodyPr wrap="square" rtlCol="0" anchor="ctr"/>
           <a:lstStyle/>
           <a:p>
-            <a:pPr indent="0" marL="0">
+            <a:pPr marL="0" indent="0">
               <a:buNone/>
             </a:pPr>
             <a:r>
@@ -6178,7 +6298,7 @@
           <a:bodyPr wrap="square" rtlCol="0" anchor="ctr"/>
           <a:lstStyle/>
           <a:p>
-            <a:pPr indent="0" marL="0">
+            <a:pPr marL="0" indent="0">
               <a:buNone/>
             </a:pPr>
             <a:r>
@@ -6244,7 +6364,7 @@
           <a:bodyPr wrap="square" rtlCol="0" anchor="ctr"/>
           <a:lstStyle/>
           <a:p>
-            <a:pPr indent="0" marL="0">
+            <a:pPr marL="0" indent="0">
               <a:buNone/>
             </a:pPr>
             <a:r>
@@ -6283,7 +6403,7 @@
           <a:bodyPr wrap="square" rtlCol="0" anchor="ctr"/>
           <a:lstStyle/>
           <a:p>
-            <a:pPr indent="0" marL="0">
+            <a:pPr marL="0" indent="0">
               <a:buNone/>
             </a:pPr>
             <a:r>
@@ -6317,6 +6437,7 @@
         <a:solidFill>
           <a:srgbClr val="0E1117"/>
         </a:solidFill>
+        <a:effectLst/>
       </p:bgPr>
     </p:bg>
     <p:spTree>
@@ -6354,11 +6475,11 @@
           <a:bodyPr wrap="square" rtlCol="0" anchor="ctr"/>
           <a:lstStyle/>
           <a:p>
-            <a:pPr indent="0" marL="0">
-              <a:buNone/>
-            </a:pPr>
-            <a:r>
-              <a:rPr lang="en-US" sz="1100" b="1" spc="500" kern="0" dirty="0">
+            <a:pPr marL="0" indent="0">
+              <a:buNone/>
+            </a:pPr>
+            <a:r>
+              <a:rPr lang="en-US" sz="1100" b="1" kern="0" spc="500" dirty="0">
                 <a:solidFill>
                   <a:srgbClr val="8A93A6"/>
                 </a:solidFill>
@@ -6393,7 +6514,7 @@
           <a:bodyPr wrap="square" rtlCol="0" anchor="ctr"/>
           <a:lstStyle/>
           <a:p>
-            <a:pPr indent="0" marL="0">
+            <a:pPr marL="0" indent="0">
               <a:buNone/>
             </a:pPr>
             <a:r>
@@ -6413,14 +6534,14 @@
       </p:sp>
       <p:pic>
         <p:nvPicPr>
-          <p:cNvPr id="4" name="Image 0" descr="assets/fig_dispatch.png">    </p:cNvPr>
+          <p:cNvPr id="4" name="Image 0" descr="assets/fig_dispatch.png"/>
           <p:cNvPicPr>
             <a:picLocks noChangeAspect="1"/>
           </p:cNvPicPr>
           <p:nvPr/>
         </p:nvPicPr>
         <p:blipFill>
-          <a:blip r:embed="rId1"/>
+          <a:blip r:embed="rId3"/>
           <a:stretch>
             <a:fillRect/>
           </a:stretch>
@@ -6483,7 +6604,7 @@
           <a:bodyPr wrap="square" rtlCol="0" anchor="ctr"/>
           <a:lstStyle/>
           <a:p>
-            <a:pPr indent="0" marL="0">
+            <a:pPr marL="0" indent="0">
               <a:buNone/>
             </a:pPr>
             <a:r>
@@ -6623,6 +6744,7 @@
         <a:solidFill>
           <a:srgbClr val="0E1117"/>
         </a:solidFill>
+        <a:effectLst/>
       </p:bgPr>
     </p:bg>
     <p:spTree>
@@ -6660,11 +6782,11 @@
           <a:bodyPr wrap="square" rtlCol="0" anchor="ctr"/>
           <a:lstStyle/>
           <a:p>
-            <a:pPr indent="0" marL="0">
-              <a:buNone/>
-            </a:pPr>
-            <a:r>
-              <a:rPr lang="en-US" sz="1100" b="1" spc="500" kern="0" dirty="0">
+            <a:pPr marL="0" indent="0">
+              <a:buNone/>
+            </a:pPr>
+            <a:r>
+              <a:rPr lang="en-US" sz="1100" b="1" kern="0" spc="500" dirty="0">
                 <a:solidFill>
                   <a:srgbClr val="8A93A6"/>
                 </a:solidFill>
@@ -6699,7 +6821,7 @@
           <a:bodyPr wrap="square" rtlCol="0" anchor="ctr"/>
           <a:lstStyle/>
           <a:p>
-            <a:pPr indent="0" marL="0">
+            <a:pPr marL="0" indent="0">
               <a:buNone/>
             </a:pPr>
             <a:r>
@@ -6765,7 +6887,7 @@
           <a:bodyPr wrap="square" rtlCol="0" anchor="ctr"/>
           <a:lstStyle/>
           <a:p>
-            <a:pPr indent="0" marL="0">
+            <a:pPr marL="0" indent="0">
               <a:buNone/>
             </a:pPr>
             <a:r>
@@ -6937,7 +7059,7 @@
           <a:bodyPr wrap="square" rtlCol="0" anchor="ctr"/>
           <a:lstStyle/>
           <a:p>
-            <a:pPr indent="0" marL="0">
+            <a:pPr marL="0" indent="0">
               <a:buNone/>
             </a:pPr>
             <a:r>
@@ -7082,7 +7204,7 @@
           <a:bodyPr wrap="square" rtlCol="0" anchor="ctr"/>
           <a:lstStyle/>
           <a:p>
-            <a:pPr indent="0" marL="0">
+            <a:pPr marL="0" indent="0">
               <a:buNone/>
             </a:pPr>
             <a:r>
@@ -7116,6 +7238,7 @@
         <a:solidFill>
           <a:srgbClr val="0E1117"/>
         </a:solidFill>
+        <a:effectLst/>
       </p:bgPr>
     </p:bg>
     <p:spTree>
@@ -7153,11 +7276,11 @@
           <a:bodyPr wrap="square" rtlCol="0" anchor="ctr"/>
           <a:lstStyle/>
           <a:p>
-            <a:pPr indent="0" marL="0">
-              <a:buNone/>
-            </a:pPr>
-            <a:r>
-              <a:rPr lang="en-US" sz="1100" b="1" spc="500" kern="0" dirty="0">
+            <a:pPr marL="0" indent="0">
+              <a:buNone/>
+            </a:pPr>
+            <a:r>
+              <a:rPr lang="en-US" sz="1100" b="1" kern="0" spc="500" dirty="0">
                 <a:solidFill>
                   <a:srgbClr val="8A93A6"/>
                 </a:solidFill>
@@ -7192,7 +7315,7 @@
           <a:bodyPr wrap="square" rtlCol="0" anchor="ctr"/>
           <a:lstStyle/>
           <a:p>
-            <a:pPr indent="0" marL="0">
+            <a:pPr marL="0" indent="0">
               <a:buNone/>
             </a:pPr>
             <a:r>
@@ -7212,14 +7335,14 @@
       </p:sp>
       <p:pic>
         <p:nvPicPr>
-          <p:cNvPr id="4" name="Image 0" descr="assets/fig_pareto.png">    </p:cNvPr>
+          <p:cNvPr id="4" name="Image 0" descr="assets/fig_pareto.png"/>
           <p:cNvPicPr>
             <a:picLocks noChangeAspect="1"/>
           </p:cNvPicPr>
           <p:nvPr/>
         </p:nvPicPr>
         <p:blipFill>
-          <a:blip r:embed="rId1"/>
+          <a:blip r:embed="rId3"/>
           <a:stretch>
             <a:fillRect/>
           </a:stretch>
@@ -7282,7 +7405,7 @@
           <a:bodyPr wrap="square" rtlCol="0" anchor="ctr"/>
           <a:lstStyle/>
           <a:p>
-            <a:pPr indent="0" marL="0">
+            <a:pPr marL="0" indent="0">
               <a:buNone/>
             </a:pPr>
             <a:r>
@@ -7707,4 +7830,299 @@
     </a:ext>
   </a:extLst>
 </a:theme>
+</file>
+
+<file path=ppt/theme/theme2.xml><?xml version="1.0" encoding="utf-8"?>
+<a:theme xmlns:a="http://schemas.openxmlformats.org/drawingml/2006/main" name="Office Theme">
+  <a:themeElements>
+    <a:clrScheme name="Office">
+      <a:dk1>
+        <a:sysClr val="windowText" lastClr="000000"/>
+      </a:dk1>
+      <a:lt1>
+        <a:sysClr val="window" lastClr="FFFFFF"/>
+      </a:lt1>
+      <a:dk2>
+        <a:srgbClr val="44546A"/>
+      </a:dk2>
+      <a:lt2>
+        <a:srgbClr val="E7E6E6"/>
+      </a:lt2>
+      <a:accent1>
+        <a:srgbClr val="4472C4"/>
+      </a:accent1>
+      <a:accent2>
+        <a:srgbClr val="ED7D31"/>
+      </a:accent2>
+      <a:accent3>
+        <a:srgbClr val="A5A5A5"/>
+      </a:accent3>
+      <a:accent4>
+        <a:srgbClr val="FFC000"/>
+      </a:accent4>
+      <a:accent5>
+        <a:srgbClr val="5B9BD5"/>
+      </a:accent5>
+      <a:accent6>
+        <a:srgbClr val="70AD47"/>
+      </a:accent6>
+      <a:hlink>
+        <a:srgbClr val="0563C1"/>
+      </a:hlink>
+      <a:folHlink>
+        <a:srgbClr val="954F72"/>
+      </a:folHlink>
+    </a:clrScheme>
+    <a:fontScheme name="Office">
+      <a:majorFont>
+        <a:latin typeface="Calibri Light" panose="020F0302020204030204"/>
+        <a:ea typeface=""/>
+        <a:cs typeface=""/>
+        <a:font script="Jpan" typeface="游ゴシック Light"/>
+        <a:font script="Hang" typeface="맑은 고딕"/>
+        <a:font script="Hans" typeface="等线 Light"/>
+        <a:font script="Hant" typeface="新細明體"/>
+        <a:font script="Arab" typeface="Times New Roman"/>
+        <a:font script="Hebr" typeface="Times New Roman"/>
+        <a:font script="Thai" typeface="Angsana New"/>
+        <a:font script="Ethi" typeface="Nyala"/>
+        <a:font script="Beng" typeface="Vrinda"/>
+        <a:font script="Gujr" typeface="Shruti"/>
+        <a:font script="Khmr" typeface="MoolBoran"/>
+        <a:font script="Knda" typeface="Tunga"/>
+        <a:font script="Guru" typeface="Raavi"/>
+        <a:font script="Cans" typeface="Euphemia"/>
+        <a:font script="Cher" typeface="Plantagenet Cherokee"/>
+        <a:font script="Yiii" typeface="Microsoft Yi Baiti"/>
+        <a:font script="Tibt" typeface="Microsoft Himalaya"/>
+        <a:font script="Thaa" typeface="MV Boli"/>
+        <a:font script="Deva" typeface="Mangal"/>
+        <a:font script="Telu" typeface="Gautami"/>
+        <a:font script="Taml" typeface="Latha"/>
+        <a:font script="Syrc" typeface="Estrangelo Edessa"/>
+        <a:font script="Orya" typeface="Kalinga"/>
+        <a:font script="Mlym" typeface="Kartika"/>
+        <a:font script="Laoo" typeface="DokChampa"/>
+        <a:font script="Sinh" typeface="Iskoola Pota"/>
+        <a:font script="Mong" typeface="Mongolian Baiti"/>
+        <a:font script="Viet" typeface="Times New Roman"/>
+        <a:font script="Uigh" typeface="Microsoft Uighur"/>
+        <a:font script="Geor" typeface="Sylfaen"/>
+        <a:font script="Armn" typeface="Arial"/>
+        <a:font script="Bugi" typeface="Leelawadee UI"/>
+        <a:font script="Bopo" typeface="Microsoft JhengHei"/>
+        <a:font script="Java" typeface="Javanese Text"/>
+        <a:font script="Lisu" typeface="Segoe UI"/>
+        <a:font script="Mymr" typeface="Myanmar Text"/>
+        <a:font script="Nkoo" typeface="Ebrima"/>
+        <a:font script="Olck" typeface="Nirmala UI"/>
+        <a:font script="Osma" typeface="Ebrima"/>
+        <a:font script="Phag" typeface="Phagspa"/>
+        <a:font script="Syrn" typeface="Estrangelo Edessa"/>
+        <a:font script="Syrj" typeface="Estrangelo Edessa"/>
+        <a:font script="Syre" typeface="Estrangelo Edessa"/>
+        <a:font script="Sora" typeface="Nirmala UI"/>
+        <a:font script="Tale" typeface="Microsoft Tai Le"/>
+        <a:font script="Talu" typeface="Microsoft New Tai Lue"/>
+        <a:font script="Tfng" typeface="Ebrima"/>
+      </a:majorFont>
+      <a:minorFont>
+        <a:latin typeface="Calibri" panose="020F0502020204030204"/>
+        <a:ea typeface=""/>
+        <a:cs typeface=""/>
+        <a:font script="Jpan" typeface="游ゴシック"/>
+        <a:font script="Hang" typeface="맑은 고딕"/>
+        <a:font script="Hans" typeface="等线"/>
+        <a:font script="Hant" typeface="新細明體"/>
+        <a:font script="Arab" typeface="Arial"/>
+        <a:font script="Hebr" typeface="Arial"/>
+        <a:font script="Thai" typeface="Cordia New"/>
+        <a:font script="Ethi" typeface="Nyala"/>
+        <a:font script="Beng" typeface="Vrinda"/>
+        <a:font script="Gujr" typeface="Shruti"/>
+        <a:font script="Khmr" typeface="DaunPenh"/>
+        <a:font script="Knda" typeface="Tunga"/>
+        <a:font script="Guru" typeface="Raavi"/>
+        <a:font script="Cans" typeface="Euphemia"/>
+        <a:font script="Cher" typeface="Plantagenet Cherokee"/>
+        <a:font script="Yiii" typeface="Microsoft Yi Baiti"/>
+        <a:font script="Tibt" typeface="Microsoft Himalaya"/>
+        <a:font script="Thaa" typeface="MV Boli"/>
+        <a:font script="Deva" typeface="Mangal"/>
+        <a:font script="Telu" typeface="Gautami"/>
+        <a:font script="Taml" typeface="Latha"/>
+        <a:font script="Syrc" typeface="Estrangelo Edessa"/>
+        <a:font script="Orya" typeface="Kalinga"/>
+        <a:font script="Mlym" typeface="Kartika"/>
+        <a:font script="Laoo" typeface="DokChampa"/>
+        <a:font script="Sinh" typeface="Iskoola Pota"/>
+        <a:font script="Mong" typeface="Mongolian Baiti"/>
+        <a:font script="Viet" typeface="Arial"/>
+        <a:font script="Uigh" typeface="Microsoft Uighur"/>
+        <a:font script="Geor" typeface="Sylfaen"/>
+        <a:font script="Armn" typeface="Arial"/>
+        <a:font script="Bugi" typeface="Leelawadee UI"/>
+        <a:font script="Bopo" typeface="Microsoft JhengHei"/>
+        <a:font script="Java" typeface="Javanese Text"/>
+        <a:font script="Lisu" typeface="Segoe UI"/>
+        <a:font script="Mymr" typeface="Myanmar Text"/>
+        <a:font script="Nkoo" typeface="Ebrima"/>
+        <a:font script="Olck" typeface="Nirmala UI"/>
+        <a:font script="Osma" typeface="Ebrima"/>
+        <a:font script="Phag" typeface="Phagspa"/>
+        <a:font script="Syrn" typeface="Estrangelo Edessa"/>
+        <a:font script="Syrj" typeface="Estrangelo Edessa"/>
+        <a:font script="Syre" typeface="Estrangelo Edessa"/>
+        <a:font script="Sora" typeface="Nirmala UI"/>
+        <a:font script="Tale" typeface="Microsoft Tai Le"/>
+        <a:font script="Talu" typeface="Microsoft New Tai Lue"/>
+        <a:font script="Tfng" typeface="Ebrima"/>
+      </a:minorFont>
+    </a:fontScheme>
+    <a:fmtScheme name="Office">
+      <a:fillStyleLst>
+        <a:solidFill>
+          <a:schemeClr val="phClr"/>
+        </a:solidFill>
+        <a:gradFill rotWithShape="1">
+          <a:gsLst>
+            <a:gs pos="0">
+              <a:schemeClr val="phClr">
+                <a:lumMod val="110000"/>
+                <a:satMod val="105000"/>
+                <a:tint val="67000"/>
+              </a:schemeClr>
+            </a:gs>
+            <a:gs pos="50000">
+              <a:schemeClr val="phClr">
+                <a:lumMod val="105000"/>
+                <a:satMod val="103000"/>
+                <a:tint val="73000"/>
+              </a:schemeClr>
+            </a:gs>
+            <a:gs pos="100000">
+              <a:schemeClr val="phClr">
+                <a:lumMod val="105000"/>
+                <a:satMod val="109000"/>
+                <a:tint val="81000"/>
+              </a:schemeClr>
+            </a:gs>
+          </a:gsLst>
+          <a:lin ang="5400000" scaled="0"/>
+        </a:gradFill>
+        <a:gradFill rotWithShape="1">
+          <a:gsLst>
+            <a:gs pos="0">
+              <a:schemeClr val="phClr">
+                <a:satMod val="103000"/>
+                <a:lumMod val="102000"/>
+                <a:tint val="94000"/>
+              </a:schemeClr>
+            </a:gs>
+            <a:gs pos="50000">
+              <a:schemeClr val="phClr">
+                <a:satMod val="110000"/>
+                <a:lumMod val="100000"/>
+                <a:shade val="100000"/>
+              </a:schemeClr>
+            </a:gs>
+            <a:gs pos="100000">
+              <a:schemeClr val="phClr">
+                <a:lumMod val="99000"/>
+                <a:satMod val="120000"/>
+                <a:shade val="78000"/>
+              </a:schemeClr>
+            </a:gs>
+          </a:gsLst>
+          <a:lin ang="5400000" scaled="0"/>
+        </a:gradFill>
+      </a:fillStyleLst>
+      <a:lnStyleLst>
+        <a:ln w="6350" cap="flat" cmpd="sng" algn="ctr">
+          <a:solidFill>
+            <a:schemeClr val="phClr"/>
+          </a:solidFill>
+          <a:prstDash val="solid"/>
+          <a:miter lim="800000"/>
+        </a:ln>
+        <a:ln w="12700" cap="flat" cmpd="sng" algn="ctr">
+          <a:solidFill>
+            <a:schemeClr val="phClr"/>
+          </a:solidFill>
+          <a:prstDash val="solid"/>
+          <a:miter lim="800000"/>
+        </a:ln>
+        <a:ln w="19050" cap="flat" cmpd="sng" algn="ctr">
+          <a:solidFill>
+            <a:schemeClr val="phClr"/>
+          </a:solidFill>
+          <a:prstDash val="solid"/>
+          <a:miter lim="800000"/>
+        </a:ln>
+      </a:lnStyleLst>
+      <a:effectStyleLst>
+        <a:effectStyle>
+          <a:effectLst/>
+        </a:effectStyle>
+        <a:effectStyle>
+          <a:effectLst/>
+        </a:effectStyle>
+        <a:effectStyle>
+          <a:effectLst>
+            <a:outerShdw blurRad="57150" dist="19050" dir="5400000" algn="ctr" rotWithShape="0">
+              <a:srgbClr val="000000">
+                <a:alpha val="63000"/>
+              </a:srgbClr>
+            </a:outerShdw>
+          </a:effectLst>
+        </a:effectStyle>
+      </a:effectStyleLst>
+      <a:bgFillStyleLst>
+        <a:solidFill>
+          <a:schemeClr val="phClr"/>
+        </a:solidFill>
+        <a:solidFill>
+          <a:schemeClr val="phClr">
+            <a:tint val="95000"/>
+            <a:satMod val="170000"/>
+          </a:schemeClr>
+        </a:solidFill>
+        <a:gradFill rotWithShape="1">
+          <a:gsLst>
+            <a:gs pos="0">
+              <a:schemeClr val="phClr">
+                <a:tint val="93000"/>
+                <a:satMod val="150000"/>
+                <a:shade val="98000"/>
+                <a:lumMod val="102000"/>
+              </a:schemeClr>
+            </a:gs>
+            <a:gs pos="50000">
+              <a:schemeClr val="phClr">
+                <a:tint val="98000"/>
+                <a:satMod val="130000"/>
+                <a:shade val="90000"/>
+                <a:lumMod val="103000"/>
+              </a:schemeClr>
+            </a:gs>
+            <a:gs pos="100000">
+              <a:schemeClr val="phClr">
+                <a:shade val="63000"/>
+                <a:satMod val="120000"/>
+              </a:schemeClr>
+            </a:gs>
+          </a:gsLst>
+          <a:lin ang="5400000" scaled="0"/>
+        </a:gradFill>
+      </a:bgFillStyleLst>
+    </a:fmtScheme>
+  </a:themeElements>
+  <a:objectDefaults/>
+  <a:extraClrSchemeLst/>
+  <a:extLst>
+    <a:ext uri="{05A4C25C-085E-4340-85A3-A5531E510DB2}">
+      <thm15:themeFamily xmlns:thm15="http://schemas.microsoft.com/office/thememl/2012/main" name="Office Theme" id="{62F939B6-93AF-4DB8-9C6B-D6C7DFDC589F}" vid="{4A3C46E8-61CC-4603-A589-7422A47A8E4A}"/>
+    </a:ext>
+  </a:extLst>
+</a:theme>
 </file>
</xml_diff>